<commit_message>
Aclara CatBoost y regularizacion L2 en la presentacion
</commit_message>
<xml_diff>
--- a/presentacion/final/Presentacion_Final_Churn_Redesign.pptx
+++ b/presentacion/final/Presentacion_Final_Churn_Redesign.pptx
@@ -4716,6 +4716,41 @@
           </a:prstGeom>
         </p:spPr>
       </p:pic>
+      <p:sp>
+        <p:nvSpPr>
+          <p:cNvPr id="34" name="TextBox 33"/>
+          <p:cNvSpPr txBox="1"/>
+          <p:nvPr/>
+        </p:nvSpPr>
+        <p:spPr>
+          <a:xfrm>
+            <a:off x="886968" y="1746504"/>
+            <a:ext cx="5806440" cy="274320"/>
+          </a:xfrm>
+          <a:prstGeom prst="rect">
+            <a:avLst/>
+          </a:prstGeom>
+          <a:noFill/>
+        </p:spPr>
+        <p:txBody>
+          <a:bodyPr wrap="none">
+            <a:spAutoFit/>
+          </a:bodyPr>
+          <a:lstStyle/>
+          <a:p>
+            <a:pPr algn="l"/>
+            <a:r>
+              <a:rPr sz="1200">
+                <a:solidFill>
+                  <a:srgbClr val="526580"/>
+                </a:solidFill>
+                <a:latin typeface="Aptos"/>
+              </a:rPr>
+              <a:t>Boosting de árboles: cada árbol corrige errores de los anteriores y el conjunto estima la probabilidad de churn.</a:t>
+            </a:r>
+          </a:p>
+        </p:txBody>
+      </p:sp>
     </p:spTree>
   </p:cSld>
   <p:clrMapOvr>
@@ -14181,7 +14216,7 @@
               <a:rPr sz="1150"/>
               <a:t>—  Es el estándar simple para clasificación binaria y entrega probabilidades de churn.
 —  Es rápida, reproducible e interpretable: sus coeficientes muestran dirección y peso.
-—  La regularización L2 reduce el riesgo de sobreajuste.
+—  La regularización L2 penaliza coeficientes grandes y reduce el riesgo de sobreajuste.
 —  Usa el mismo pipeline, variables y folds: la comparación es justa.
 —  Supera al Dummy y alcanza PR-AUC CV = 0,660.</a:t>
             </a:r>

</xml_diff>